<commit_message>
sd-02-007: do not route every event through the gateway or a second cluster
The source does not say which events pass the event gateway, and sharding
by domain puts each event in one cluster; the cost named is that the
producer must know the domain. Lesson and deck (PPTX re-exported) updated.

Co-Authored-By: Claude Opus 5.5 <noreply@anthropic.com>
Claude-Session: https://claude.ai/code/session_01McBLtMnJbTnB94NeVs8a2V
</commit_message>
<xml_diff>
--- a/system-design-101/vi/lessons/sd-02-007/slides/sd-02-007.pptx
+++ b/system-design-101/vi/lessons/sd-02-007/slides/sd-02-007.pptx
@@ -9047,10 +9047,10 @@
                 <a:ea typeface="Bricolage Grotesque ExtraBold" pitchFamily="34" charset="-122"/>
                 <a:cs typeface="Bricolage Grotesque ExtraBold" pitchFamily="34" charset="-120"/>
               </a:rPr>
-              <a:t> kiện từ</a:t>
-            </a:r>
-            <a:r>
-              <a:rPr lang="en-US" sz="3600" dirty="0" spc="-4" kern="0">
+              <a:t> kiện</a:t>
+            </a:r>
+            <a:r>
+              <a:rPr lang="en-US" sz="3600" dirty="0" spc="-32" kern="0">
                 <a:solidFill>
                   <a:srgbClr val="14161C"/>
                 </a:solidFill>
@@ -9058,10 +9058,10 @@
                 <a:ea typeface="Bricolage Grotesque ExtraBold" pitchFamily="34" charset="-122"/>
                 <a:cs typeface="Bricolage Grotesque ExtraBold" pitchFamily="34" charset="-120"/>
               </a:rPr>
-              <a:t> một</a:t>
-            </a:r>
-            <a:r>
-              <a:rPr lang="en-US" sz="3600" dirty="0" spc="9" kern="0">
+              <a:t> tới</a:t>
+            </a:r>
+            <a:r>
+              <a:rPr lang="en-US" sz="3600" dirty="0" spc="3" kern="0">
                 <a:solidFill>
                   <a:srgbClr val="14161C"/>
                 </a:solidFill>
@@ -9069,7 +9069,7 @@
                 <a:ea typeface="Bricolage Grotesque ExtraBold" pitchFamily="34" charset="-122"/>
                 <a:cs typeface="Bricolage Grotesque ExtraBold" pitchFamily="34" charset="-120"/>
               </a:rPr>
-              <a:t> đội</a:t>
+              <a:t> cổng</a:t>
             </a:r>
             <a:endParaRPr lang="en-US" sz="3600" dirty="0"/>
           </a:p>
@@ -9436,7 +9436,7 @@
               <a:buNone/>
             </a:pPr>
             <a:r>
-              <a:rPr lang="en-US" sz="2058" b="1" dirty="0" spc="-13" kern="0">
+              <a:rPr lang="en-US" sz="2058" b="1" dirty="0" spc="11" kern="0">
                 <a:solidFill>
                   <a:srgbClr val="14161C"/>
                 </a:solidFill>
@@ -9444,10 +9444,10 @@
                 <a:ea typeface="Be Vietnam Pro" pitchFamily="34" charset="-122"/>
                 <a:cs typeface="Be Vietnam Pro" pitchFamily="34" charset="-120"/>
               </a:rPr>
-              <a:t>vào</a:t>
-            </a:r>
-            <a:r>
-              <a:rPr lang="en-US" sz="2058" b="1" dirty="0" spc="-5" kern="0">
+              <a:t>được</a:t>
+            </a:r>
+            <a:r>
+              <a:rPr lang="en-US" sz="2058" b="1" dirty="0" spc="1" kern="0">
                 <a:solidFill>
                   <a:srgbClr val="14161C"/>
                 </a:solidFill>
@@ -9455,18 +9455,7 @@
                 <a:ea typeface="Be Vietnam Pro" pitchFamily="34" charset="-122"/>
                 <a:cs typeface="Be Vietnam Pro" pitchFamily="34" charset="-120"/>
               </a:rPr>
-              <a:t> hệ</a:t>
-            </a:r>
-            <a:r>
-              <a:rPr lang="en-US" sz="2058" b="1" dirty="0" spc="-3" kern="0">
-                <a:solidFill>
-                  <a:srgbClr val="14161C"/>
-                </a:solidFill>
-                <a:latin typeface="Be Vietnam Pro" pitchFamily="34" charset="0"/>
-                <a:ea typeface="Be Vietnam Pro" pitchFamily="34" charset="-122"/>
-                <a:cs typeface="Be Vietnam Pro" pitchFamily="34" charset="-120"/>
-              </a:rPr>
-              <a:t> thống</a:t>
+              <a:t> nhận</a:t>
             </a:r>
             <a:endParaRPr lang="en-US" sz="2058" dirty="0"/>
           </a:p>
@@ -13305,6 +13294,28 @@
               <a:buChar char="•"/>
             </a:pPr>
             <a:r>
+              <a:rPr lang="en-US" sz="2700" dirty="0" spc="-5" kern="0">
+                <a:solidFill>
+                  <a:srgbClr val="14161C"/>
+                </a:solidFill>
+                <a:latin typeface="Be Vietnam Pro" pitchFamily="34" charset="0"/>
+                <a:ea typeface="Be Vietnam Pro" pitchFamily="34" charset="-122"/>
+                <a:cs typeface="Be Vietnam Pro" pitchFamily="34" charset="-120"/>
+              </a:rPr>
+              <a:t>Bên</a:t>
+            </a:r>
+            <a:r>
+              <a:rPr lang="en-US" sz="2700" dirty="0" spc="-11" kern="0">
+                <a:solidFill>
+                  <a:srgbClr val="14161C"/>
+                </a:solidFill>
+                <a:latin typeface="Be Vietnam Pro" pitchFamily="34" charset="0"/>
+                <a:ea typeface="Be Vietnam Pro" pitchFamily="34" charset="-122"/>
+                <a:cs typeface="Be Vietnam Pro" pitchFamily="34" charset="-120"/>
+              </a:rPr>
+              <a:t> phát</a:t>
+            </a:r>
+            <a:r>
               <a:rPr lang="en-US" sz="2700" dirty="0" spc="-1" kern="0">
                 <a:solidFill>
                   <a:srgbClr val="14161C"/>
@@ -13313,10 +13324,10 @@
                 <a:ea typeface="Be Vietnam Pro" pitchFamily="34" charset="-122"/>
                 <a:cs typeface="Be Vietnam Pro" pitchFamily="34" charset="-120"/>
               </a:rPr>
-              <a:t>Sự</a:t>
-            </a:r>
-            <a:r>
-              <a:rPr lang="en-US" sz="2700" dirty="0" spc="-3" kern="0">
+              <a:t> phải</a:t>
+            </a:r>
+            <a:r>
+              <a:rPr lang="en-US" sz="2700" dirty="0" spc="-7" kern="0">
                 <a:solidFill>
                   <a:srgbClr val="14161C"/>
                 </a:solidFill>
@@ -13324,7 +13335,7 @@
                 <a:ea typeface="Be Vietnam Pro" pitchFamily="34" charset="-122"/>
                 <a:cs typeface="Be Vietnam Pro" pitchFamily="34" charset="-120"/>
               </a:rPr>
-              <a:t> kiện</a:t>
+              <a:t> biết</a:t>
             </a:r>
             <a:r>
               <a:rPr lang="en-US" sz="2700" dirty="0" spc="-2" kern="0">
@@ -13335,10 +13346,10 @@
                 <a:ea typeface="Be Vietnam Pro" pitchFamily="34" charset="-122"/>
                 <a:cs typeface="Be Vietnam Pro" pitchFamily="34" charset="-120"/>
               </a:rPr>
-              <a:t> hai</a:t>
-            </a:r>
-            <a:r>
-              <a:rPr lang="en-US" sz="2700" dirty="0" spc="-3" kern="0">
+              <a:t> miền</a:t>
+            </a:r>
+            <a:r>
+              <a:rPr lang="en-US" sz="2700" dirty="0" spc="14" kern="0">
                 <a:solidFill>
                   <a:srgbClr val="14161C"/>
                 </a:solidFill>
@@ -13346,7 +13357,7 @@
                 <a:ea typeface="Be Vietnam Pro" pitchFamily="34" charset="-122"/>
                 <a:cs typeface="Be Vietnam Pro" pitchFamily="34" charset="-120"/>
               </a:rPr>
-              <a:t> miền</a:t>
+              <a:t> để</a:t>
             </a:r>
             <a:r>
               <a:rPr lang="en-US" sz="2700" dirty="0" spc="-1" kern="0">
@@ -13357,29 +13368,7 @@
                 <a:ea typeface="Be Vietnam Pro" pitchFamily="34" charset="-122"/>
                 <a:cs typeface="Be Vietnam Pro" pitchFamily="34" charset="-120"/>
               </a:rPr>
-              <a:t> phải</a:t>
-            </a:r>
-            <a:r>
-              <a:rPr lang="en-US" sz="2700" dirty="0" spc="-2" kern="0">
-                <a:solidFill>
-                  <a:srgbClr val="14161C"/>
-                </a:solidFill>
-                <a:latin typeface="Be Vietnam Pro" pitchFamily="34" charset="0"/>
-                <a:ea typeface="Be Vietnam Pro" pitchFamily="34" charset="-122"/>
-                <a:cs typeface="Be Vietnam Pro" pitchFamily="34" charset="-120"/>
-              </a:rPr>
-              <a:t> qua hai</a:t>
-            </a:r>
-            <a:r>
-              <a:rPr lang="en-US" sz="2700" dirty="0" spc="-3" kern="0">
-                <a:solidFill>
-                  <a:srgbClr val="14161C"/>
-                </a:solidFill>
-                <a:latin typeface="Be Vietnam Pro" pitchFamily="34" charset="0"/>
-                <a:ea typeface="Be Vietnam Pro" pitchFamily="34" charset="-122"/>
-                <a:cs typeface="Be Vietnam Pro" pitchFamily="34" charset="-120"/>
-              </a:rPr>
-              <a:t> nơi.</a:t>
+              <a:t> chọn cụm.</a:t>
             </a:r>
             <a:endParaRPr lang="en-US" sz="2700" dirty="0"/>
           </a:p>

</xml_diff>

<commit_message>
sd-02-007: standardizing and scaling are two layers, not a stated order
Co-Authored-By: Claude Opus 5.5 <noreply@anthropic.com>
Claude-Session: https://claude.ai/code/session_01McBLtMnJbTnB94NeVs8a2V
</commit_message>
<xml_diff>
--- a/system-design-101/vi/lessons/sd-02-007/slides/sd-02-007.pptx
+++ b/system-design-101/vi/lessons/sd-02-007/slides/sd-02-007.pptx
@@ -1864,7 +1864,7 @@
               <a:t> kiện</a:t>
             </a:r>
             <a:r>
-              <a:rPr lang="en-US" sz="8100" dirty="0" spc="-76" kern="0">
+              <a:rPr lang="en-US" sz="8100" dirty="0" spc="-86" kern="0">
                 <a:solidFill>
                   <a:srgbClr val="F3EEE3"/>
                 </a:solidFill>
@@ -1872,7 +1872,7 @@
                 <a:ea typeface="Bricolage Grotesque ExtraBold" pitchFamily="34" charset="-122"/>
                 <a:cs typeface="Bricolage Grotesque ExtraBold" pitchFamily="34" charset="-120"/>
               </a:rPr>
-              <a:t> trước,</a:t>
+              <a:t> và</a:t>
             </a:r>
             <a:r>
               <a:rPr lang="en-US" sz="8100" dirty="0" spc="-2" kern="0">
@@ -1895,17 +1895,6 @@
                 <a:cs typeface="Bricolage Grotesque ExtraBold" pitchFamily="34" charset="-120"/>
               </a:rPr>
               <a:t> rộng</a:t>
-            </a:r>
-            <a:r>
-              <a:rPr lang="en-US" sz="8100" dirty="0" spc="-3" kern="0">
-                <a:solidFill>
-                  <a:srgbClr val="F3EEE3"/>
-                </a:solidFill>
-                <a:latin typeface="Bricolage Grotesque ExtraBold" pitchFamily="34" charset="0"/>
-                <a:ea typeface="Bricolage Grotesque ExtraBold" pitchFamily="34" charset="-122"/>
-                <a:cs typeface="Bricolage Grotesque ExtraBold" pitchFamily="34" charset="-120"/>
-              </a:rPr>
-              <a:t> sau</a:t>
             </a:r>
             <a:endParaRPr lang="en-US" sz="8100" dirty="0"/>
           </a:p>
@@ -5450,6 +5439,72 @@
               <a:buChar char="•"/>
             </a:pPr>
             <a:r>
+              <a:rPr lang="en-US" sz="2850" dirty="0" spc="-2" kern="0">
+                <a:solidFill>
+                  <a:srgbClr val="14161C"/>
+                </a:solidFill>
+                <a:latin typeface="Be Vietnam Pro" pitchFamily="34" charset="0"/>
+                <a:ea typeface="Be Vietnam Pro" pitchFamily="34" charset="-122"/>
+                <a:cs typeface="Be Vietnam Pro" pitchFamily="34" charset="-120"/>
+              </a:rPr>
+              <a:t>Cách</a:t>
+            </a:r>
+            <a:r>
+              <a:rPr lang="en-US" sz="2850" dirty="0" spc="-13" kern="0">
+                <a:solidFill>
+                  <a:srgbClr val="14161C"/>
+                </a:solidFill>
+                <a:latin typeface="Be Vietnam Pro" pitchFamily="34" charset="0"/>
+                <a:ea typeface="Be Vietnam Pro" pitchFamily="34" charset="-122"/>
+                <a:cs typeface="Be Vietnam Pro" pitchFamily="34" charset="-120"/>
+              </a:rPr>
+              <a:t> tách</a:t>
+            </a:r>
+            <a:r>
+              <a:rPr lang="en-US" sz="2850" dirty="0" spc="3" kern="0">
+                <a:solidFill>
+                  <a:srgbClr val="14161C"/>
+                </a:solidFill>
+                <a:latin typeface="Be Vietnam Pro" pitchFamily="34" charset="0"/>
+                <a:ea typeface="Be Vietnam Pro" pitchFamily="34" charset="-122"/>
+                <a:cs typeface="Be Vietnam Pro" pitchFamily="34" charset="-120"/>
+              </a:rPr>
+              <a:t> hai</a:t>
+            </a:r>
+            <a:r>
+              <a:rPr lang="en-US" sz="2850" dirty="0" spc="0" kern="0">
+                <a:solidFill>
+                  <a:srgbClr val="14161C"/>
+                </a:solidFill>
+                <a:latin typeface="Be Vietnam Pro" pitchFamily="34" charset="0"/>
+                <a:ea typeface="Be Vietnam Pro" pitchFamily="34" charset="-122"/>
+                <a:cs typeface="Be Vietnam Pro" pitchFamily="34" charset="-120"/>
+              </a:rPr>
+              <a:t> lớp</a:t>
+            </a:r>
+            <a:r>
+              <a:rPr lang="en-US" sz="2850" dirty="0" spc="2" kern="0">
+                <a:solidFill>
+                  <a:srgbClr val="14161C"/>
+                </a:solidFill>
+                <a:latin typeface="Be Vietnam Pro" pitchFamily="34" charset="0"/>
+                <a:ea typeface="Be Vietnam Pro" pitchFamily="34" charset="-122"/>
+                <a:cs typeface="Be Vietnam Pro" pitchFamily="34" charset="-120"/>
+              </a:rPr>
+              <a:t> là</a:t>
+            </a:r>
+            <a:r>
+              <a:rPr lang="en-US" sz="2850" dirty="0" spc="1" kern="0">
+                <a:solidFill>
+                  <a:srgbClr val="14161C"/>
+                </a:solidFill>
+                <a:latin typeface="Be Vietnam Pro" pitchFamily="34" charset="0"/>
+                <a:ea typeface="Be Vietnam Pro" pitchFamily="34" charset="-122"/>
+                <a:cs typeface="Be Vietnam Pro" pitchFamily="34" charset="-120"/>
+              </a:rPr>
+              <a:t> của</a:t>
+            </a:r>
+            <a:r>
               <a:rPr lang="en-US" sz="2850" dirty="0" spc="-3" kern="0">
                 <a:solidFill>
                   <a:srgbClr val="14161C"/>
@@ -5458,73 +5513,18 @@
                 <a:ea typeface="Be Vietnam Pro" pitchFamily="34" charset="-122"/>
                 <a:cs typeface="Be Vietnam Pro" pitchFamily="34" charset="-120"/>
               </a:rPr>
-              <a:t>Theo</a:t>
-            </a:r>
-            <a:r>
-              <a:rPr lang="en-US" sz="2850" dirty="0" spc="-2" kern="0">
-                <a:solidFill>
-                  <a:srgbClr val="14161C"/>
-                </a:solidFill>
-                <a:latin typeface="Be Vietnam Pro" pitchFamily="34" charset="0"/>
-                <a:ea typeface="Be Vietnam Pro" pitchFamily="34" charset="-122"/>
-                <a:cs typeface="Be Vietnam Pro" pitchFamily="34" charset="-120"/>
-              </a:rPr>
-              <a:t> nguồn,</a:t>
-            </a:r>
-            <a:r>
-              <a:rPr lang="en-US" sz="2850" dirty="0" spc="1" kern="0">
-                <a:solidFill>
-                  <a:srgbClr val="14161C"/>
-                </a:solidFill>
-                <a:latin typeface="Be Vietnam Pro" pitchFamily="34" charset="0"/>
-                <a:ea typeface="Be Vietnam Pro" pitchFamily="34" charset="-122"/>
-                <a:cs typeface="Be Vietnam Pro" pitchFamily="34" charset="-120"/>
-              </a:rPr>
-              <a:t> McDonald's</a:t>
-            </a:r>
-            <a:r>
-              <a:rPr lang="en-US" sz="2850" dirty="0" spc="-1" kern="0">
-                <a:solidFill>
-                  <a:srgbClr val="14161C"/>
-                </a:solidFill>
-                <a:latin typeface="Be Vietnam Pro" pitchFamily="34" charset="0"/>
-                <a:ea typeface="Be Vietnam Pro" pitchFamily="34" charset="-122"/>
-                <a:cs typeface="Be Vietnam Pro" pitchFamily="34" charset="-120"/>
-              </a:rPr>
-              <a:t> làm</a:t>
-            </a:r>
-            <a:r>
-              <a:rPr lang="en-US" sz="2850" dirty="0" spc="0" kern="0">
-                <a:solidFill>
-                  <a:srgbClr val="14161C"/>
-                </a:solidFill>
-                <a:latin typeface="Be Vietnam Pro" pitchFamily="34" charset="0"/>
-                <a:ea typeface="Be Vietnam Pro" pitchFamily="34" charset="-122"/>
-                <a:cs typeface="Be Vietnam Pro" pitchFamily="34" charset="-120"/>
-              </a:rPr>
-              <a:t> lớp</a:t>
-            </a:r>
-            <a:r>
-              <a:rPr lang="en-US" sz="2850" dirty="0" spc="-9" kern="0">
-                <a:solidFill>
-                  <a:srgbClr val="14161C"/>
-                </a:solidFill>
-                <a:latin typeface="Be Vietnam Pro" pitchFamily="34" charset="0"/>
-                <a:ea typeface="Be Vietnam Pro" pitchFamily="34" charset="-122"/>
-                <a:cs typeface="Be Vietnam Pro" pitchFamily="34" charset="-120"/>
-              </a:rPr>
-              <a:t> một</a:t>
-            </a:r>
-            <a:r>
-              <a:rPr lang="en-US" sz="2850" dirty="0" spc="7" kern="0">
-                <a:solidFill>
-                  <a:srgbClr val="14161C"/>
-                </a:solidFill>
-                <a:latin typeface="Be Vietnam Pro" pitchFamily="34" charset="0"/>
-                <a:ea typeface="Be Vietnam Pro" pitchFamily="34" charset="-122"/>
-                <a:cs typeface="Be Vietnam Pro" pitchFamily="34" charset="-120"/>
-              </a:rPr>
-              <a:t> trước.</a:t>
+              <a:t> bài</a:t>
+            </a:r>
+            <a:r>
+              <a:rPr lang="en-US" sz="2850" dirty="0" spc="-8" kern="0">
+                <a:solidFill>
+                  <a:srgbClr val="14161C"/>
+                </a:solidFill>
+                <a:latin typeface="Be Vietnam Pro" pitchFamily="34" charset="0"/>
+                <a:ea typeface="Be Vietnam Pro" pitchFamily="34" charset="-122"/>
+                <a:cs typeface="Be Vietnam Pro" pitchFamily="34" charset="-120"/>
+              </a:rPr>
+              <a:t> này.</a:t>
             </a:r>
             <a:endParaRPr lang="en-US" sz="2850" dirty="0"/>
           </a:p>

</xml_diff>